<commit_message>
docs: correct Veylott demo URL
</commit_message>
<xml_diff>
--- a/docs/showcase/presentation/Veylott-Presentation.pptx
+++ b/docs/showcase/presentation/Veylott-Presentation.pptx
@@ -3561,7 +3561,7 @@
                 <a:latin typeface="Liberation Mono"/>
                 <a:hlinkClick r:id="rId2"/>
               </a:rPr>
-              <a:t>veylott.vercel.app</a:t>
+              <a:t>Open the Veylott live demo</a:t>
             </a:r>
           </a:p>
         </p:txBody>
@@ -4462,7 +4462,7 @@
                 <a:latin typeface="Liberation Mono"/>
                 <a:hlinkClick r:id="rId2"/>
               </a:rPr>
-              <a:t>veylott.vercel.app</a:t>
+              <a:t>Open the Veylott live demo</a:t>
             </a:r>
           </a:p>
         </p:txBody>
@@ -9293,7 +9293,7 @@
                 </a:solidFill>
                 <a:latin typeface="Liberation Mono"/>
               </a:rPr>
-              <a:t>Captured from https://veylott.vercel.app · 4 Sep 2026</a:t>
+              <a:t>Captured from the Veylott live demo · 4 Sep 2026</a:t>
             </a:r>
           </a:p>
         </p:txBody>

</xml_diff>

<commit_message>
docs: finalize verified bounty submission package
</commit_message>
<xml_diff>
--- a/docs/showcase/presentation/Veylott-Presentation.pptx
+++ b/docs/showcase/presentation/Veylott-Presentation.pptx
@@ -3866,7 +3866,7 @@
         <p:spPr>
           <a:xfrm>
             <a:off x="685800" y="5349240"/>
-            <a:ext cx="2468880" cy="292608"/>
+            <a:ext cx="2788920" cy="292608"/>
           </a:xfrm>
           <a:prstGeom prst="roundRect">
             <a:avLst/>
@@ -3911,7 +3911,7 @@
         <p:spPr>
           <a:xfrm>
             <a:off x="758952" y="5367527"/>
-            <a:ext cx="2322576" cy="219456"/>
+            <a:ext cx="2642615" cy="219456"/>
           </a:xfrm>
           <a:prstGeom prst="rect">
             <a:avLst/>
@@ -3936,7 +3936,7 @@
                 </a:solidFill>
                 <a:latin typeface="Liberation Sans"/>
               </a:rPr>
-              <a:t>RESEARCH SOFTWARE · NOT PRODUCTION</a:t>
+              <a:t>UNAUDITED RESEARCH · NOT PRODUCTION</a:t>
             </a:r>
           </a:p>
         </p:txBody>
@@ -4524,6 +4524,90 @@
         </p:nvSpPr>
         <p:spPr>
           <a:xfrm>
+            <a:off x="685800" y="5349240"/>
+            <a:ext cx="2971800" cy="292608"/>
+          </a:xfrm>
+          <a:prstGeom prst="roundRect">
+            <a:avLst/>
+          </a:prstGeom>
+          <a:solidFill>
+            <a:srgbClr val="FFF4D6"/>
+          </a:solidFill>
+          <a:ln w="12700">
+            <a:solidFill>
+              <a:srgbClr val="FFF4D6"/>
+            </a:solidFill>
+          </a:ln>
+        </p:spPr>
+        <p:style>
+          <a:lnRef idx="1">
+            <a:schemeClr val="accent1"/>
+          </a:lnRef>
+          <a:fillRef idx="3">
+            <a:schemeClr val="accent1"/>
+          </a:fillRef>
+          <a:effectRef idx="2">
+            <a:schemeClr val="accent1"/>
+          </a:effectRef>
+          <a:fontRef idx="minor">
+            <a:schemeClr val="lt1"/>
+          </a:fontRef>
+        </p:style>
+        <p:txBody>
+          <a:bodyPr rtlCol="0" anchor="ctr"/>
+          <a:lstStyle/>
+          <a:p>
+            <a:pPr algn="ctr"/>
+          </a:p>
+        </p:txBody>
+      </p:sp>
+      <p:sp>
+        <p:nvSpPr>
+          <p:cNvPr id="15" name="TextBox 14"/>
+          <p:cNvSpPr txBox="1"/>
+          <p:nvPr/>
+        </p:nvSpPr>
+        <p:spPr>
+          <a:xfrm>
+            <a:off x="758952" y="5367527"/>
+            <a:ext cx="2825496" cy="219456"/>
+          </a:xfrm>
+          <a:prstGeom prst="rect">
+            <a:avLst/>
+          </a:prstGeom>
+          <a:noFill/>
+        </p:spPr>
+        <p:txBody>
+          <a:bodyPr wrap="none" lIns="18288" rIns="18288" tIns="18288" bIns="18288" anchor="ctr">
+            <a:spAutoFit/>
+          </a:bodyPr>
+          <a:lstStyle/>
+          <a:p>
+            <a:pPr algn="l">
+              <a:lnSpc>
+                <a:spcPct val="100000"/>
+              </a:lnSpc>
+            </a:pPr>
+            <a:r>
+              <a:rPr sz="800" b="1">
+                <a:solidFill>
+                  <a:srgbClr val="915200"/>
+                </a:solidFill>
+                <a:latin typeface="Liberation Sans"/>
+              </a:rPr>
+              <a:t>UNAUDITED · SPONSOR-FUNDED · MAX 12</a:t>
+            </a:r>
+          </a:p>
+        </p:txBody>
+      </p:sp>
+      <p:sp>
+        <p:nvSpPr>
+          <p:cNvPr id="16" name="Rounded Rectangle 15"/>
+          <p:cNvSpPr/>
+          <p:nvPr/>
+        </p:nvSpPr>
+        <p:spPr>
+          <a:xfrm>
             <a:off x="7863840" y="1417320"/>
             <a:ext cx="3429000" cy="4251960"/>
           </a:xfrm>
@@ -4563,7 +4647,7 @@
       </p:sp>
       <p:sp>
         <p:nvSpPr>
-          <p:cNvPr id="15" name="TextBox 14"/>
+          <p:cNvPr id="17" name="TextBox 16"/>
           <p:cNvSpPr txBox="1"/>
           <p:nvPr/>
         </p:nvSpPr>
@@ -4602,7 +4686,7 @@
       </p:sp>
       <p:sp>
         <p:nvSpPr>
-          <p:cNvPr id="16" name="TextBox 15"/>
+          <p:cNvPr id="18" name="TextBox 17"/>
           <p:cNvSpPr txBox="1"/>
           <p:nvPr/>
         </p:nvSpPr>
@@ -4634,18 +4718,18 @@
                 </a:solidFill>
                 <a:latin typeface="Liberation Mono"/>
               </a:rPr>
-              <a:t>0x54FdC46D
-0EA722Ef
-A4853192
-678b35fC
-ABFad99C</a:t>
-            </a:r>
-          </a:p>
-        </p:txBody>
-      </p:sp>
-      <p:sp>
-        <p:nvSpPr>
-          <p:cNvPr id="17" name="Rounded Rectangle 16"/>
+              <a:t>0x2150d7D8
+2117b927
+Dd325393
+5E34f67D
+8B37d424</a:t>
+            </a:r>
+          </a:p>
+        </p:txBody>
+      </p:sp>
+      <p:sp>
+        <p:nvSpPr>
+          <p:cNvPr id="19" name="Rounded Rectangle 18"/>
           <p:cNvSpPr/>
           <p:nvPr/>
         </p:nvSpPr>
@@ -4690,7 +4774,7 @@
       </p:sp>
       <p:sp>
         <p:nvSpPr>
-          <p:cNvPr id="18" name="TextBox 17"/>
+          <p:cNvPr id="20" name="TextBox 19"/>
           <p:cNvSpPr txBox="1"/>
           <p:nvPr/>
         </p:nvSpPr>
@@ -4729,7 +4813,7 @@
       </p:sp>
       <p:sp>
         <p:nvSpPr>
-          <p:cNvPr id="19" name="TextBox 18"/>
+          <p:cNvPr id="21" name="TextBox 20"/>
           <p:cNvSpPr txBox="1"/>
           <p:nvPr/>
         </p:nvSpPr>
@@ -6405,7 +6489,7 @@
               <a:t>• Deposited testnet cUSDC
 • Contract and custody bindings
 • Transaction receipts
-• Aggregate solvency</a:t>
+• Runtime and policy</a:t>
             </a:r>
           </a:p>
         </p:txBody>
@@ -7877,7 +7961,7 @@
                 <a:latin typeface="Liberation Sans"/>
               </a:rPr>
               <a:t>Prepares authorized proofs
-Verifies public snapshots</a:t>
+Returns proof-bound bits</a:t>
             </a:r>
           </a:p>
         </p:txBody>
@@ -9293,7 +9377,7 @@
                 </a:solidFill>
                 <a:latin typeface="Liberation Mono"/>
               </a:rPr>
-              <a:t>Captured from the Veylott live demo · 4 Sep 2026</a:t>
+              <a:t>Captured from the canonical Veylott deployment · 5 Sep 2026</a:t>
             </a:r>
           </a:p>
         </p:txBody>
@@ -11766,7 +11850,7 @@
                 </a:solidFill>
                 <a:latin typeface="Liberation Sans"/>
               </a:rPr>
-              <a:t>Bound draw proofs</a:t>
+              <a:t>Private settlement</a:t>
             </a:r>
           </a:p>
         </p:txBody>
@@ -11805,7 +11889,7 @@
                 </a:solidFill>
                 <a:latin typeface="Liberation Sans"/>
               </a:rPr>
-              <a:t>KMS evidence must match the stored aggregate and reserve handles.</a:t>
+              <a:t>KMS evidence reveals only a request-bound readiness bit; aggregate amounts stay encrypted.</a:t>
             </a:r>
           </a:p>
         </p:txBody>
@@ -12399,7 +12483,7 @@
                 </a:solidFill>
                 <a:latin typeface="Liberation Sans"/>
               </a:rPr>
-              <a:t>A completed historical prize round—not a simulated receipt</a:t>
+              <a:t>A real three-wallet round on the active pool</a:t>
             </a:r>
           </a:p>
         </p:txBody>
@@ -12438,7 +12522,7 @@
                 </a:solidFill>
                 <a:latin typeface="Liberation Sans"/>
               </a:rPr>
-              <a:t>Each transaction below links directly to its confirmed predecessor-deployment receipt.</a:t>
+              <a:t>Each transaction links directly to a confirmed Sepolia receipt; no result is simulated.</a:t>
             </a:r>
           </a:p>
         </p:txBody>
@@ -12606,7 +12690,7 @@
                 </a:solidFill>
                 <a:latin typeface="Liberation Sans"/>
               </a:rPr>
-              <a:t>cUSDC deposit</a:t>
+              <a:t>Encrypted deposit</a:t>
             </a:r>
           </a:p>
         </p:txBody>
@@ -12655,7 +12739,7 @@
                 <a:latin typeface="Liberation Mono"/>
                 <a:hlinkClick r:id="rId2"/>
               </a:rPr>
-              <a:t>0xe36db7…b39f</a:t>
+              <a:t>0x5fcdac…c676</a:t>
             </a:r>
           </a:p>
         </p:txBody>
@@ -12694,7 +12778,7 @@
                 </a:solidFill>
                 <a:latin typeface="Liberation Sans"/>
               </a:rPr>
-              <a:t>Encrypted position</a:t>
+              <a:t>3 wallets activated</a:t>
             </a:r>
           </a:p>
         </p:txBody>
@@ -12862,7 +12946,7 @@
                 </a:solidFill>
                 <a:latin typeface="Liberation Sans"/>
               </a:rPr>
-              <a:t>KMS draw</a:t>
+              <a:t>Readiness KMS</a:t>
             </a:r>
           </a:p>
         </p:txBody>
@@ -12911,7 +12995,7 @@
                 <a:latin typeface="Liberation Mono"/>
                 <a:hlinkClick r:id="rId3"/>
               </a:rPr>
-              <a:t>0x504862…ce6c</a:t>
+              <a:t>0x0970ff…b320</a:t>
             </a:r>
           </a:p>
         </p:txBody>
@@ -13167,7 +13251,7 @@
                 <a:latin typeface="Liberation Mono"/>
                 <a:hlinkClick r:id="rId4"/>
               </a:rPr>
-              <a:t>0x5763be…c969</a:t>
+              <a:t>0xb8f291…d50a</a:t>
             </a:r>
           </a:p>
         </p:txBody>
@@ -13290,7 +13374,7 @@
                 </a:solidFill>
                 <a:latin typeface="Liberation Sans"/>
               </a:rPr>
-              <a:t>Deposit → KMS draw → private claim → principal withdrawal · all confirmed</a:t>
+              <a:t>3 deposits → draw 1 → private claim → all exits → participant count 0</a:t>
             </a:r>
           </a:p>
         </p:txBody>
@@ -13329,7 +13413,7 @@
                 </a:solidFill>
                 <a:latin typeface="Liberation Mono"/>
               </a:rPr>
-              <a:t>Full hashes and runtime evidence: docs/operations/sepolia-deployment.md</a:t>
+              <a:t>Full hashes and runtime evidence: docs/operations/live-prize-lifecycle.md</a:t>
             </a:r>
           </a:p>
         </p:txBody>
@@ -13761,7 +13845,7 @@
                 </a:solidFill>
                 <a:latin typeface="Liberation Sans"/>
               </a:rPr>
-              <a:t>FULL</a:t>
+              <a:t>163</a:t>
             </a:r>
           </a:p>
         </p:txBody>
@@ -13800,7 +13884,7 @@
                 </a:solidFill>
                 <a:latin typeface="Liberation Mono"/>
               </a:rPr>
-              <a:t>VALIDATION SUITE</a:t>
+              <a:t>TESTS PASSING</a:t>
             </a:r>
           </a:p>
         </p:txBody>
@@ -14545,7 +14629,7 @@
                 </a:solidFill>
                 <a:latin typeface="Liberation Sans"/>
               </a:rPr>
-              <a:t>Indexer checkpoint restored successfully after a live service restart</a:t>
+              <a:t>Audit-scope verifier binds source, bytecode, custody and policy across 2 RPCs</a:t>
             </a:r>
           </a:p>
         </p:txBody>

</xml_diff>